<commit_message>
PPT : précision sur le taux de retard, chiffres de la recommandation seuil Connect, limite reformulée
</commit_message>
<xml_diff>
--- a/Presentation_Getaround_Soutenance.pptx
+++ b/Presentation_Getaround_Soutenance.pptx
@@ -5022,7 +5022,7 @@
               </a:defRPr>
             </a:pPr>
             <a:r>
-              <a:t>•  Le seuil recommandé est estimé sur les locations consécutives connues : c'est une borne haute du revenu impacté.</a:t>
+              <a:t>•  Le revenu impacté est compté en nombre de locations bloquées, à revenu supposé identique par location (pas de montants dans les données).</a:t>
             </a:r>
           </a:p>
           <a:p>
@@ -7358,7 +7358,7 @@
               </a:defRPr>
             </a:pPr>
             <a:r>
-              <a:t>checkouts en retard</a:t>
+              <a:t>locations rendues en retard</a:t>
             </a:r>
           </a:p>
           <a:p>
@@ -7370,7 +7370,7 @@
               </a:defRPr>
             </a:pPr>
             <a:r>
-              <a:t>retard &gt; 0 min</a:t>
+              <a:t>57 % parmi les 16 346 retards renseignés</a:t>
             </a:r>
           </a:p>
         </p:txBody>
@@ -7518,7 +7518,7 @@
               </a:defRPr>
             </a:pPr>
             <a:r>
-              <a:t>•  Recommandation : 60 à 90 min sur les voitures Connect.</a:t>
+              <a:t>•  Recommandation : 60 à 90 min sur les voitures Connect : 70 à 81 % des cas résolus pour 4 à 6 % des locations Connect bloquées.</a:t>
             </a:r>
           </a:p>
         </p:txBody>

</xml_diff>

<commit_message>
Deux périmètres présentés (toutes / Connect) : tableau seuil × scope dans le PPT, texte neutre dans le dashboard
</commit_message>
<xml_diff>
--- a/Presentation_Getaround_Soutenance.pptx
+++ b/Presentation_Getaround_Soutenance.pptx
@@ -983,12 +983,17 @@
           </a:p>
           <a:p>
             <a:r>
-              <a:t>44 % des locations sont rendues en retard. Sur les locations consécutives, 11,8 % des clients suivants sont impactés.</a:t>
-            </a:r>
-          </a:p>
-          <a:p>
-            <a:r>
-              <a:t>Le dashboard permet de simuler le seuil et le périmètre, et de lire le trade-off entre revenu perdu et cas résolus.</a:t>
+              <a:t>44 % des locations sont rendues en retard (57 % de celles dont le retard est renseigné). Sur les locations consécutives, 11,8 % des clients suivants sont impactés.</a:t>
+            </a:r>
+          </a:p>
+          <a:p>
+            <a:r>
+              <a:t>Le dashboard permet de simuler le seuil ET le périmètre. Les deux périmètres sont présentés : sur toutes les voitures, un seuil de 90 min résout 79 % des cas pour 2,7 % des locations bloquées ; sur Connect seulement, 81 % pour 6 % des locations Connect.</a:t>
+            </a:r>
+          </a:p>
+          <a:p>
+            <a:r>
+              <a:t>Je ne tranche pas à la place du PM : je lui donne les deux lectures. Si on me demande mon avis : Connect est le périmètre où la mesure est techniquement applicable (ouverture à distance), c'est un bon point de départ avant d'étendre.</a:t>
             </a:r>
           </a:p>
         </p:txBody>
@@ -7463,8 +7468,544 @@
         </p:nvSpPr>
         <p:spPr>
           <a:xfrm>
-            <a:off x="548640" y="3108960"/>
-            <a:ext cx="5349240" cy="2743200"/>
+            <a:off x="548640" y="3063240"/>
+            <a:ext cx="5349240" cy="457200"/>
+          </a:xfrm>
+          <a:prstGeom prst="rect">
+            <a:avLst/>
+          </a:prstGeom>
+          <a:noFill/>
+        </p:spPr>
+        <p:txBody>
+          <a:bodyPr wrap="square" anchor="t">
+            <a:spAutoFit/>
+          </a:bodyPr>
+          <a:lstStyle/>
+          <a:p>
+            <a:pPr>
+              <a:spcAft>
+                <a:spcPts val="600"/>
+              </a:spcAft>
+              <a:defRPr sz="1500" b="1">
+                <a:solidFill>
+                  <a:srgbClr val="6A1B9A"/>
+                </a:solidFill>
+              </a:defRPr>
+            </a:pPr>
+            <a:r>
+              <a:t>Seuil × périmètre : ce que le PM peut lire dans le dashboard</a:t>
+            </a:r>
+          </a:p>
+        </p:txBody>
+      </p:sp>
+      <p:graphicFrame>
+        <p:nvGraphicFramePr>
+          <p:cNvPr id="11" name="Table 10"/>
+          <p:cNvGraphicFramePr>
+            <a:graphicFrameLocks noGrp="1"/>
+          </p:cNvGraphicFramePr>
+          <p:nvPr/>
+        </p:nvGraphicFramePr>
+        <p:xfrm>
+          <a:off x="548640" y="3520440"/>
+          <a:ext cx="5349240" cy="1737360"/>
+        </p:xfrm>
+        <a:graphic>
+          <a:graphicData uri="http://schemas.openxmlformats.org/drawingml/2006/table">
+            <a:tbl>
+              <a:tblPr firstRow="1" bandRow="1">
+                <a:tableStyleId>{5C22544A-7EE6-4342-B048-85BDC9FD1C3A}</a:tableStyleId>
+              </a:tblPr>
+              <a:tblGrid>
+                <a:gridCol w="1965960"/>
+                <a:gridCol w="822960"/>
+                <a:gridCol w="1371600"/>
+                <a:gridCol w="1188720"/>
+              </a:tblGrid>
+              <a:tr h="347472">
+                <a:tc>
+                  <a:txBody>
+                    <a:bodyPr/>
+                    <a:lstStyle/>
+                    <a:p>
+                      <a:pPr algn="l">
+                        <a:defRPr sz="1200" b="1">
+                          <a:solidFill>
+                            <a:srgbClr val="FFFFFF"/>
+                          </a:solidFill>
+                        </a:defRPr>
+                      </a:pPr>
+                      <a:r>
+                        <a:t>Périmètre</a:t>
+                      </a:r>
+                    </a:p>
+                  </a:txBody>
+                  <a:tcPr marT="27432" marB="27432">
+                    <a:solidFill>
+                      <a:srgbClr val="6A1B9A"/>
+                    </a:solidFill>
+                  </a:tcPr>
+                </a:tc>
+                <a:tc>
+                  <a:txBody>
+                    <a:bodyPr/>
+                    <a:lstStyle/>
+                    <a:p>
+                      <a:pPr algn="ctr">
+                        <a:defRPr sz="1200" b="1">
+                          <a:solidFill>
+                            <a:srgbClr val="FFFFFF"/>
+                          </a:solidFill>
+                        </a:defRPr>
+                      </a:pPr>
+                      <a:r>
+                        <a:t>Seuil</a:t>
+                      </a:r>
+                    </a:p>
+                  </a:txBody>
+                  <a:tcPr marT="27432" marB="27432">
+                    <a:solidFill>
+                      <a:srgbClr val="6A1B9A"/>
+                    </a:solidFill>
+                  </a:tcPr>
+                </a:tc>
+                <a:tc>
+                  <a:txBody>
+                    <a:bodyPr/>
+                    <a:lstStyle/>
+                    <a:p>
+                      <a:pPr algn="ctr">
+                        <a:defRPr sz="1200" b="1">
+                          <a:solidFill>
+                            <a:srgbClr val="FFFFFF"/>
+                          </a:solidFill>
+                        </a:defRPr>
+                      </a:pPr>
+                      <a:r>
+                        <a:t>Locations bloquées</a:t>
+                      </a:r>
+                    </a:p>
+                  </a:txBody>
+                  <a:tcPr marT="27432" marB="27432">
+                    <a:solidFill>
+                      <a:srgbClr val="6A1B9A"/>
+                    </a:solidFill>
+                  </a:tcPr>
+                </a:tc>
+                <a:tc>
+                  <a:txBody>
+                    <a:bodyPr/>
+                    <a:lstStyle/>
+                    <a:p>
+                      <a:pPr algn="ctr">
+                        <a:defRPr sz="1200" b="1">
+                          <a:solidFill>
+                            <a:srgbClr val="FFFFFF"/>
+                          </a:solidFill>
+                        </a:defRPr>
+                      </a:pPr>
+                      <a:r>
+                        <a:t>Cas résolus</a:t>
+                      </a:r>
+                    </a:p>
+                  </a:txBody>
+                  <a:tcPr marT="27432" marB="27432">
+                    <a:solidFill>
+                      <a:srgbClr val="6A1B9A"/>
+                    </a:solidFill>
+                  </a:tcPr>
+                </a:tc>
+              </a:tr>
+              <a:tr h="347472">
+                <a:tc>
+                  <a:txBody>
+                    <a:bodyPr/>
+                    <a:lstStyle/>
+                    <a:p>
+                      <a:pPr algn="l">
+                        <a:defRPr sz="1200" b="0">
+                          <a:solidFill>
+                            <a:srgbClr val="4A475E"/>
+                          </a:solidFill>
+                        </a:defRPr>
+                      </a:pPr>
+                      <a:r>
+                        <a:t>Toutes les voitures</a:t>
+                      </a:r>
+                    </a:p>
+                  </a:txBody>
+                  <a:tcPr marT="27432" marB="27432">
+                    <a:solidFill>
+                      <a:srgbClr val="FFFFFF"/>
+                    </a:solidFill>
+                  </a:tcPr>
+                </a:tc>
+                <a:tc>
+                  <a:txBody>
+                    <a:bodyPr/>
+                    <a:lstStyle/>
+                    <a:p>
+                      <a:pPr algn="ctr">
+                        <a:defRPr sz="1200" b="0">
+                          <a:solidFill>
+                            <a:srgbClr val="4A475E"/>
+                          </a:solidFill>
+                        </a:defRPr>
+                      </a:pPr>
+                      <a:r>
+                        <a:t>60 min</a:t>
+                      </a:r>
+                    </a:p>
+                  </a:txBody>
+                  <a:tcPr marT="27432" marB="27432">
+                    <a:solidFill>
+                      <a:srgbClr val="FFFFFF"/>
+                    </a:solidFill>
+                  </a:tcPr>
+                </a:tc>
+                <a:tc>
+                  <a:txBody>
+                    <a:bodyPr/>
+                    <a:lstStyle/>
+                    <a:p>
+                      <a:pPr algn="ctr">
+                        <a:defRPr sz="1200" b="0">
+                          <a:solidFill>
+                            <a:srgbClr val="4A475E"/>
+                          </a:solidFill>
+                        </a:defRPr>
+                      </a:pPr>
+                      <a:r>
+                        <a:t>1,9 %</a:t>
+                      </a:r>
+                    </a:p>
+                  </a:txBody>
+                  <a:tcPr marT="27432" marB="27432">
+                    <a:solidFill>
+                      <a:srgbClr val="FFFFFF"/>
+                    </a:solidFill>
+                  </a:tcPr>
+                </a:tc>
+                <a:tc>
+                  <a:txBody>
+                    <a:bodyPr/>
+                    <a:lstStyle/>
+                    <a:p>
+                      <a:pPr algn="ctr">
+                        <a:defRPr sz="1200" b="0">
+                          <a:solidFill>
+                            <a:srgbClr val="4A475E"/>
+                          </a:solidFill>
+                        </a:defRPr>
+                      </a:pPr>
+                      <a:r>
+                        <a:t>67 %</a:t>
+                      </a:r>
+                    </a:p>
+                  </a:txBody>
+                  <a:tcPr marT="27432" marB="27432">
+                    <a:solidFill>
+                      <a:srgbClr val="FFFFFF"/>
+                    </a:solidFill>
+                  </a:tcPr>
+                </a:tc>
+              </a:tr>
+              <a:tr h="347472">
+                <a:tc>
+                  <a:txBody>
+                    <a:bodyPr/>
+                    <a:lstStyle/>
+                    <a:p>
+                      <a:pPr algn="l">
+                        <a:defRPr sz="1200" b="0">
+                          <a:solidFill>
+                            <a:srgbClr val="4A475E"/>
+                          </a:solidFill>
+                        </a:defRPr>
+                      </a:pPr>
+                      <a:r>
+                        <a:t>Toutes les voitures</a:t>
+                      </a:r>
+                    </a:p>
+                  </a:txBody>
+                  <a:tcPr marT="27432" marB="27432">
+                    <a:solidFill>
+                      <a:srgbClr val="FFFFFF"/>
+                    </a:solidFill>
+                  </a:tcPr>
+                </a:tc>
+                <a:tc>
+                  <a:txBody>
+                    <a:bodyPr/>
+                    <a:lstStyle/>
+                    <a:p>
+                      <a:pPr algn="ctr">
+                        <a:defRPr sz="1200" b="0">
+                          <a:solidFill>
+                            <a:srgbClr val="4A475E"/>
+                          </a:solidFill>
+                        </a:defRPr>
+                      </a:pPr>
+                      <a:r>
+                        <a:t>90 min</a:t>
+                      </a:r>
+                    </a:p>
+                  </a:txBody>
+                  <a:tcPr marT="27432" marB="27432">
+                    <a:solidFill>
+                      <a:srgbClr val="FFFFFF"/>
+                    </a:solidFill>
+                  </a:tcPr>
+                </a:tc>
+                <a:tc>
+                  <a:txBody>
+                    <a:bodyPr/>
+                    <a:lstStyle/>
+                    <a:p>
+                      <a:pPr algn="ctr">
+                        <a:defRPr sz="1200" b="0">
+                          <a:solidFill>
+                            <a:srgbClr val="4A475E"/>
+                          </a:solidFill>
+                        </a:defRPr>
+                      </a:pPr>
+                      <a:r>
+                        <a:t>2,7 %</a:t>
+                      </a:r>
+                    </a:p>
+                  </a:txBody>
+                  <a:tcPr marT="27432" marB="27432">
+                    <a:solidFill>
+                      <a:srgbClr val="FFFFFF"/>
+                    </a:solidFill>
+                  </a:tcPr>
+                </a:tc>
+                <a:tc>
+                  <a:txBody>
+                    <a:bodyPr/>
+                    <a:lstStyle/>
+                    <a:p>
+                      <a:pPr algn="ctr">
+                        <a:defRPr sz="1200" b="0">
+                          <a:solidFill>
+                            <a:srgbClr val="4A475E"/>
+                          </a:solidFill>
+                        </a:defRPr>
+                      </a:pPr>
+                      <a:r>
+                        <a:t>79 %</a:t>
+                      </a:r>
+                    </a:p>
+                  </a:txBody>
+                  <a:tcPr marT="27432" marB="27432">
+                    <a:solidFill>
+                      <a:srgbClr val="FFFFFF"/>
+                    </a:solidFill>
+                  </a:tcPr>
+                </a:tc>
+              </a:tr>
+              <a:tr h="347472">
+                <a:tc>
+                  <a:txBody>
+                    <a:bodyPr/>
+                    <a:lstStyle/>
+                    <a:p>
+                      <a:pPr algn="l">
+                        <a:defRPr sz="1200" b="0">
+                          <a:solidFill>
+                            <a:srgbClr val="4A475E"/>
+                          </a:solidFill>
+                        </a:defRPr>
+                      </a:pPr>
+                      <a:r>
+                        <a:t>Connect seulement</a:t>
+                      </a:r>
+                    </a:p>
+                  </a:txBody>
+                  <a:tcPr marT="27432" marB="27432">
+                    <a:solidFill>
+                      <a:srgbClr val="FFFFFF"/>
+                    </a:solidFill>
+                  </a:tcPr>
+                </a:tc>
+                <a:tc>
+                  <a:txBody>
+                    <a:bodyPr/>
+                    <a:lstStyle/>
+                    <a:p>
+                      <a:pPr algn="ctr">
+                        <a:defRPr sz="1200" b="0">
+                          <a:solidFill>
+                            <a:srgbClr val="4A475E"/>
+                          </a:solidFill>
+                        </a:defRPr>
+                      </a:pPr>
+                      <a:r>
+                        <a:t>60 min</a:t>
+                      </a:r>
+                    </a:p>
+                  </a:txBody>
+                  <a:tcPr marT="27432" marB="27432">
+                    <a:solidFill>
+                      <a:srgbClr val="FFFFFF"/>
+                    </a:solidFill>
+                  </a:tcPr>
+                </a:tc>
+                <a:tc>
+                  <a:txBody>
+                    <a:bodyPr/>
+                    <a:lstStyle/>
+                    <a:p>
+                      <a:pPr algn="ctr">
+                        <a:defRPr sz="1200" b="0">
+                          <a:solidFill>
+                            <a:srgbClr val="4A475E"/>
+                          </a:solidFill>
+                        </a:defRPr>
+                      </a:pPr>
+                      <a:r>
+                        <a:t>4,2 %</a:t>
+                      </a:r>
+                    </a:p>
+                  </a:txBody>
+                  <a:tcPr marT="27432" marB="27432">
+                    <a:solidFill>
+                      <a:srgbClr val="FFFFFF"/>
+                    </a:solidFill>
+                  </a:tcPr>
+                </a:tc>
+                <a:tc>
+                  <a:txBody>
+                    <a:bodyPr/>
+                    <a:lstStyle/>
+                    <a:p>
+                      <a:pPr algn="ctr">
+                        <a:defRPr sz="1200" b="0">
+                          <a:solidFill>
+                            <a:srgbClr val="4A475E"/>
+                          </a:solidFill>
+                        </a:defRPr>
+                      </a:pPr>
+                      <a:r>
+                        <a:t>70 %</a:t>
+                      </a:r>
+                    </a:p>
+                  </a:txBody>
+                  <a:tcPr marT="27432" marB="27432">
+                    <a:solidFill>
+                      <a:srgbClr val="FFFFFF"/>
+                    </a:solidFill>
+                  </a:tcPr>
+                </a:tc>
+              </a:tr>
+              <a:tr h="347472">
+                <a:tc>
+                  <a:txBody>
+                    <a:bodyPr/>
+                    <a:lstStyle/>
+                    <a:p>
+                      <a:pPr algn="l">
+                        <a:defRPr sz="1200" b="0">
+                          <a:solidFill>
+                            <a:srgbClr val="4A475E"/>
+                          </a:solidFill>
+                        </a:defRPr>
+                      </a:pPr>
+                      <a:r>
+                        <a:t>Connect seulement</a:t>
+                      </a:r>
+                    </a:p>
+                  </a:txBody>
+                  <a:tcPr marT="27432" marB="27432">
+                    <a:solidFill>
+                      <a:srgbClr val="FFFFFF"/>
+                    </a:solidFill>
+                  </a:tcPr>
+                </a:tc>
+                <a:tc>
+                  <a:txBody>
+                    <a:bodyPr/>
+                    <a:lstStyle/>
+                    <a:p>
+                      <a:pPr algn="ctr">
+                        <a:defRPr sz="1200" b="0">
+                          <a:solidFill>
+                            <a:srgbClr val="4A475E"/>
+                          </a:solidFill>
+                        </a:defRPr>
+                      </a:pPr>
+                      <a:r>
+                        <a:t>90 min</a:t>
+                      </a:r>
+                    </a:p>
+                  </a:txBody>
+                  <a:tcPr marT="27432" marB="27432">
+                    <a:solidFill>
+                      <a:srgbClr val="FFFFFF"/>
+                    </a:solidFill>
+                  </a:tcPr>
+                </a:tc>
+                <a:tc>
+                  <a:txBody>
+                    <a:bodyPr/>
+                    <a:lstStyle/>
+                    <a:p>
+                      <a:pPr algn="ctr">
+                        <a:defRPr sz="1200" b="0">
+                          <a:solidFill>
+                            <a:srgbClr val="4A475E"/>
+                          </a:solidFill>
+                        </a:defRPr>
+                      </a:pPr>
+                      <a:r>
+                        <a:t>6,0 %</a:t>
+                      </a:r>
+                    </a:p>
+                  </a:txBody>
+                  <a:tcPr marT="27432" marB="27432">
+                    <a:solidFill>
+                      <a:srgbClr val="FFFFFF"/>
+                    </a:solidFill>
+                  </a:tcPr>
+                </a:tc>
+                <a:tc>
+                  <a:txBody>
+                    <a:bodyPr/>
+                    <a:lstStyle/>
+                    <a:p>
+                      <a:pPr algn="ctr">
+                        <a:defRPr sz="1200" b="0">
+                          <a:solidFill>
+                            <a:srgbClr val="4A475E"/>
+                          </a:solidFill>
+                        </a:defRPr>
+                      </a:pPr>
+                      <a:r>
+                        <a:t>81 %</a:t>
+                      </a:r>
+                    </a:p>
+                  </a:txBody>
+                  <a:tcPr marT="27432" marB="27432">
+                    <a:solidFill>
+                      <a:srgbClr val="FFFFFF"/>
+                    </a:solidFill>
+                  </a:tcPr>
+                </a:tc>
+              </a:tr>
+            </a:tbl>
+          </a:graphicData>
+        </a:graphic>
+      </p:graphicFrame>
+      <p:sp>
+        <p:nvSpPr>
+          <p:cNvPr id="12" name="TextBox 11"/>
+          <p:cNvSpPr txBox="1"/>
+          <p:nvPr/>
+        </p:nvSpPr>
+        <p:spPr>
+          <a:xfrm>
+            <a:off x="548640" y="5349240"/>
+            <a:ext cx="5349240" cy="640080"/>
           </a:xfrm>
           <a:prstGeom prst="rect">
             <a:avLst/>
@@ -7481,51 +8022,21 @@
               <a:spcAft>
                 <a:spcPts val="700"/>
               </a:spcAft>
-              <a:defRPr sz="1500" b="0">
+              <a:defRPr sz="1200" b="0">
                 <a:solidFill>
                   <a:srgbClr val="4A475E"/>
                 </a:solidFill>
               </a:defRPr>
             </a:pPr>
             <a:r>
-              <a:t>•  Le PM règle le seuil (0 à 720 min) et le périmètre (toutes / Connect).</a:t>
-            </a:r>
-          </a:p>
-          <a:p>
-            <a:pPr>
-              <a:spcAft>
-                <a:spcPts val="700"/>
-              </a:spcAft>
-              <a:defRPr sz="1500" b="0">
-                <a:solidFill>
-                  <a:srgbClr val="4A475E"/>
-                </a:solidFill>
-              </a:defRPr>
-            </a:pPr>
-            <a:r>
-              <a:t>•  Le dashboard affiche le revenu impacté, les locations bloquées et les cas résolus.</a:t>
-            </a:r>
-          </a:p>
-          <a:p>
-            <a:pPr>
-              <a:spcAft>
-                <a:spcPts val="700"/>
-              </a:spcAft>
-              <a:defRPr sz="1500" b="0">
-                <a:solidFill>
-                  <a:srgbClr val="4A475E"/>
-                </a:solidFill>
-              </a:defRPr>
-            </a:pPr>
-            <a:r>
-              <a:t>•  Recommandation : 60 à 90 min sur les voitures Connect : 70 à 81 % des cas résolus pour 4 à 6 % des locations Connect bloquées.</a:t>
+              <a:t>Le seuil résout la majorité des cas dès 60-90 min ; le périmètre est un arbitrage revenu / friction que le dashboard laisse au PM.</a:t>
             </a:r>
           </a:p>
         </p:txBody>
       </p:sp>
       <p:pic>
         <p:nvPicPr>
-          <p:cNvPr id="11" name="Picture 10" descr="dashboard_analyse_crop.png"/>
+          <p:cNvPr id="13" name="Picture 12" descr="dashboard_analyse_crop.png"/>
           <p:cNvPicPr>
             <a:picLocks noChangeAspect="1"/>
           </p:cNvPicPr>
@@ -7554,7 +8065,7 @@
       </p:pic>
       <p:sp>
         <p:nvSpPr>
-          <p:cNvPr id="12" name="TextBox 11"/>
+          <p:cNvPr id="14" name="TextBox 13"/>
           <p:cNvSpPr txBox="1"/>
           <p:nvPr/>
         </p:nvSpPr>
@@ -7589,7 +8100,7 @@
       </p:sp>
       <p:sp>
         <p:nvSpPr>
-          <p:cNvPr id="13" name="TextBox 12"/>
+          <p:cNvPr id="15" name="TextBox 14"/>
           <p:cNvSpPr txBox="1"/>
           <p:nvPr/>
         </p:nvSpPr>
@@ -7623,7 +8134,7 @@
       </p:sp>
       <p:sp>
         <p:nvSpPr>
-          <p:cNvPr id="14" name="TextBox 13"/>
+          <p:cNvPr id="16" name="TextBox 15"/>
           <p:cNvSpPr txBox="1"/>
           <p:nvPr/>
         </p:nvSpPr>
@@ -7658,7 +8169,7 @@
       </p:sp>
       <p:sp>
         <p:nvSpPr>
-          <p:cNvPr id="15" name="TextBox 14"/>
+          <p:cNvPr id="17" name="TextBox 16"/>
           <p:cNvSpPr txBox="1"/>
           <p:nvPr/>
         </p:nvSpPr>

</xml_diff>

<commit_message>
Suppression de l'ancienne présentation, date de soutenance mise à jour
</commit_message>
<xml_diff>
--- a/Presentation_Getaround_Soutenance.pptx
+++ b/Presentation_Getaround_Soutenance.pptx
@@ -4634,7 +4634,7 @@
               </a:defRPr>
             </a:pPr>
             <a:r>
-              <a:t>Soutenance du 30 septembre 2026</a:t>
+              <a:t>Soutenance du 1er octobre 2026</a:t>
             </a:r>
           </a:p>
         </p:txBody>
@@ -4737,7 +4737,7 @@
               </a:defRPr>
             </a:pPr>
             <a:r>
-              <a:t>Aymeric Lahonde  ·  Bloc 5 Getaround  ·  CDSD Jedha (RNCP 35288)  ·  30/09/2026</a:t>
+              <a:t>Aymeric Lahonde  ·  Bloc 5 Getaround  ·  CDSD Jedha (RNCP 35288)  ·  01/10/2026</a:t>
             </a:r>
           </a:p>
         </p:txBody>
@@ -5122,7 +5122,7 @@
               </a:defRPr>
             </a:pPr>
             <a:r>
-              <a:t>Aymeric Lahonde  ·  Bloc 5 Getaround  ·  CDSD Jedha (RNCP 35288)  ·  30/09/2026</a:t>
+              <a:t>Aymeric Lahonde  ·  Bloc 5 Getaround  ·  CDSD Jedha (RNCP 35288)  ·  01/10/2026</a:t>
             </a:r>
           </a:p>
         </p:txBody>
@@ -5507,7 +5507,7 @@
               </a:defRPr>
             </a:pPr>
             <a:r>
-              <a:t>Aymeric Lahonde  ·  Bloc 5 Getaround  ·  CDSD Jedha (RNCP 35288)  ·  30/09/2026</a:t>
+              <a:t>Aymeric Lahonde  ·  Bloc 5 Getaround  ·  CDSD Jedha (RNCP 35288)  ·  01/10/2026</a:t>
             </a:r>
           </a:p>
         </p:txBody>
@@ -6038,7 +6038,7 @@
               </a:defRPr>
             </a:pPr>
             <a:r>
-              <a:t>Aymeric Lahonde  ·  Bloc 5 Getaround  ·  CDSD Jedha (RNCP 35288)  ·  30/09/2026</a:t>
+              <a:t>Aymeric Lahonde  ·  Bloc 5 Getaround  ·  CDSD Jedha (RNCP 35288)  ·  01/10/2026</a:t>
             </a:r>
           </a:p>
         </p:txBody>
@@ -6465,7 +6465,7 @@
               </a:defRPr>
             </a:pPr>
             <a:r>
-              <a:t>Aymeric Lahonde  ·  Bloc 5 Getaround  ·  CDSD Jedha (RNCP 35288)  ·  30/09/2026</a:t>
+              <a:t>Aymeric Lahonde  ·  Bloc 5 Getaround  ·  CDSD Jedha (RNCP 35288)  ·  01/10/2026</a:t>
             </a:r>
           </a:p>
         </p:txBody>
@@ -6963,7 +6963,7 @@
               </a:defRPr>
             </a:pPr>
             <a:r>
-              <a:t>Aymeric Lahonde  ·  Bloc 5 Getaround  ·  CDSD Jedha (RNCP 35288)  ·  30/09/2026</a:t>
+              <a:t>Aymeric Lahonde  ·  Bloc 5 Getaround  ·  CDSD Jedha (RNCP 35288)  ·  01/10/2026</a:t>
             </a:r>
           </a:p>
         </p:txBody>
@@ -8162,7 +8162,7 @@
               </a:defRPr>
             </a:pPr>
             <a:r>
-              <a:t>Aymeric Lahonde  ·  Bloc 5 Getaround  ·  CDSD Jedha (RNCP 35288)  ·  30/09/2026</a:t>
+              <a:t>Aymeric Lahonde  ·  Bloc 5 Getaround  ·  CDSD Jedha (RNCP 35288)  ·  01/10/2026</a:t>
             </a:r>
           </a:p>
         </p:txBody>
@@ -9166,7 +9166,7 @@
               </a:defRPr>
             </a:pPr>
             <a:r>
-              <a:t>Aymeric Lahonde  ·  Bloc 5 Getaround  ·  CDSD Jedha (RNCP 35288)  ·  30/09/2026</a:t>
+              <a:t>Aymeric Lahonde  ·  Bloc 5 Getaround  ·  CDSD Jedha (RNCP 35288)  ·  01/10/2026</a:t>
             </a:r>
           </a:p>
         </p:txBody>
@@ -9776,7 +9776,7 @@
               </a:defRPr>
             </a:pPr>
             <a:r>
-              <a:t>Aymeric Lahonde  ·  Bloc 5 Getaround  ·  CDSD Jedha (RNCP 35288)  ·  30/09/2026</a:t>
+              <a:t>Aymeric Lahonde  ·  Bloc 5 Getaround  ·  CDSD Jedha (RNCP 35288)  ·  01/10/2026</a:t>
             </a:r>
           </a:p>
         </p:txBody>
@@ -10673,7 +10673,7 @@
               </a:defRPr>
             </a:pPr>
             <a:r>
-              <a:t>Aymeric Lahonde  ·  Bloc 5 Getaround  ·  CDSD Jedha (RNCP 35288)  ·  30/09/2026</a:t>
+              <a:t>Aymeric Lahonde  ·  Bloc 5 Getaround  ·  CDSD Jedha (RNCP 35288)  ·  01/10/2026</a:t>
             </a:r>
           </a:p>
         </p:txBody>
@@ -11439,7 +11439,7 @@
               </a:defRPr>
             </a:pPr>
             <a:r>
-              <a:t>Aymeric Lahonde  ·  Bloc 5 Getaround  ·  CDSD Jedha (RNCP 35288)  ·  30/09/2026</a:t>
+              <a:t>Aymeric Lahonde  ·  Bloc 5 Getaround  ·  CDSD Jedha (RNCP 35288)  ·  01/10/2026</a:t>
             </a:r>
           </a:p>
         </p:txBody>
@@ -11969,7 +11969,7 @@
               </a:defRPr>
             </a:pPr>
             <a:r>
-              <a:t>Aymeric Lahonde  ·  Bloc 5 Getaround  ·  CDSD Jedha (RNCP 35288)  ·  30/09/2026</a:t>
+              <a:t>Aymeric Lahonde  ·  Bloc 5 Getaround  ·  CDSD Jedha (RNCP 35288)  ·  01/10/2026</a:t>
             </a:r>
           </a:p>
         </p:txBody>

</xml_diff>